<commit_message>
deck: multi-field layouts in, slide 8 gains the field-envelope plot
Slide 8 (the t4 second instrument) now pairs the solid view -- cropped
by the generator to the iso + side panels so they stay legible at slide
scale (deck_t4_layout_isoside.png, generated at build) -- with the S5
field-envelope elevation.  Slides 1-7 pick up the regenerated
multi-field solid layouts.  Slide-1/2 dedup edits from the style gate
retained.  Rebuilt from the committed records; layout inspected
slide-by-slide.

Also commits run_s5_budget.m -- the S5 long-budget probe (leg A: 9
solve fields at iteration cap 150; leg B: 25 solve fields at 60), both
from the S4-of-record start under the full constraint rows; artifacts
land in s5_budget/ when the run completes (running now).

Co-Authored-By: Claude Fable 5 <noreply@anthropic.com>
</commit_message>
<xml_diff>
--- a/mmacos/challenges/rodgers3/deck_rodgers3.pptx
+++ b/mmacos/challenges/rodgers3/deck_rodgers3.pptx
@@ -7628,7 +7628,7 @@
       </p:sp>
       <p:pic>
         <p:nvPicPr>
-          <p:cNvPr id="6" name="Picture 5" descr="t4_s5_layout.png"/>
+          <p:cNvPr id="6" name="Picture 5" descr="deck_t4_layout_isoside.png"/>
           <p:cNvPicPr>
             <a:picLocks noChangeAspect="1"/>
           </p:cNvPicPr>
@@ -7642,8 +7642,8 @@
         </p:blipFill>
         <p:spPr>
           <a:xfrm>
-            <a:off x="7469298" y="1298448"/>
-            <a:ext cx="3257962" cy="2806192"/>
+            <a:off x="6400800" y="1298448"/>
+            <a:ext cx="5394960" cy="2232314"/>
           </a:xfrm>
           <a:prstGeom prst="rect">
             <a:avLst/>
@@ -7658,7 +7658,7 @@
         </p:nvSpPr>
         <p:spPr>
           <a:xfrm>
-            <a:off x="6400800" y="4122927"/>
+            <a:off x="6400800" y="3549050"/>
             <a:ext cx="5394960" cy="394208"/>
           </a:xfrm>
           <a:prstGeom prst="rect">
@@ -7684,20 +7684,83 @@
                 </a:solidFill>
                 <a:latin typeface="Arial"/>
               </a:rPr>
-              <a:t>The second instrument at S5: the same five-stage flow, different parameters, clearances to its own spec.</a:t>
-            </a:r>
-          </a:p>
-        </p:txBody>
-      </p:sp>
-      <p:sp>
-        <p:nvSpPr>
-          <p:cNvPr id="8" name="TextBox 7"/>
+              <a:t>The second instrument at S5 (iso + side): the same five-stage flow at different parameters.</a:t>
+            </a:r>
+          </a:p>
+        </p:txBody>
+      </p:sp>
+      <p:pic>
+        <p:nvPicPr>
+          <p:cNvPr id="8" name="Picture 7" descr="t4_s5_fields.png"/>
+          <p:cNvPicPr>
+            <a:picLocks noChangeAspect="1"/>
+          </p:cNvPicPr>
+          <p:nvPr/>
+        </p:nvPicPr>
+        <p:blipFill>
+          <a:blip r:embed="rId3"/>
+          <a:stretch>
+            <a:fillRect/>
+          </a:stretch>
+        </p:blipFill>
+        <p:spPr>
+          <a:xfrm>
+            <a:off x="7872277" y="3979834"/>
+            <a:ext cx="2452005" cy="1708912"/>
+          </a:xfrm>
+          <a:prstGeom prst="rect">
+            <a:avLst/>
+          </a:prstGeom>
+        </p:spPr>
+      </p:pic>
+      <p:sp>
+        <p:nvSpPr>
+          <p:cNvPr id="9" name="TextBox 8"/>
           <p:cNvSpPr txBox="1"/>
           <p:nvPr/>
         </p:nvSpPr>
         <p:spPr>
           <a:xfrm>
-            <a:off x="6400800" y="4553712"/>
+            <a:off x="6400800" y="5707034"/>
+            <a:ext cx="5394960" cy="394208"/>
+          </a:xfrm>
+          <a:prstGeom prst="rect">
+            <a:avLst/>
+          </a:prstGeom>
+          <a:noFill/>
+        </p:spPr>
+        <p:txBody>
+          <a:bodyPr wrap="square">
+            <a:spAutoFit/>
+          </a:bodyPr>
+          <a:lstStyle/>
+          <a:p>
+            <a:pPr algn="ctr">
+              <a:spcAft>
+                <a:spcPts val="0"/>
+              </a:spcAft>
+            </a:pPr>
+            <a:r>
+              <a:rPr sz="1000" b="0">
+                <a:solidFill>
+                  <a:srgbClr val="6E6E6E"/>
+                </a:solidFill>
+                <a:latin typeface="Arial"/>
+              </a:rPr>
+              <a:t>S5 field envelopes: centre + YAN-extreme beams clear every mirror at the instrument's own 10/5 mm spec.</a:t>
+            </a:r>
+          </a:p>
+        </p:txBody>
+      </p:sp>
+      <p:sp>
+        <p:nvSpPr>
+          <p:cNvPr id="10" name="TextBox 9"/>
+          <p:cNvSpPr txBox="1"/>
+          <p:nvPr/>
+        </p:nvSpPr>
+        <p:spPr>
+          <a:xfrm>
+            <a:off x="6400800" y="6137818"/>
             <a:ext cx="5394960" cy="274320"/>
           </a:xfrm>
           <a:prstGeom prst="rect">
@@ -7723,7 +7786,7 @@
                 </a:solidFill>
                 <a:latin typeface="Arial"/>
               </a:rPr>
-              <a:t>strict RMS WFE, centroid reference on the stage's frozen focal plane, exit-pupil anchor, piston-only removal; quoted statistic = dense 11x11 map MAXIMUM over the field box (this instrument's box).  Reproduce: rodgers3() — the Stage-0 gates; oi_story(...) — ladder + counters + this deck's numbers; suites tRodgers3 + tOffsetImager.  Written record: challenges/rodgers3/PACKET.md.</a:t>
+              <a:t>strict RMS WFE, centroid reference on the stage's frozen focal plane, exit-pupil anchor, piston-only removal; quoted statistic = dense 11x11 map MAXIMUM over the field box (this instrument's box).  Reproduce: rodgers3() = the Stage-0 gates, oi_story(...) = ladder + counters; record: challenges/rodgers3/PACKET.md.</a:t>
             </a:r>
           </a:p>
         </p:txBody>

</xml_diff>

<commit_message>
decks: the sequel -- redemption + continuation walk (F16), parsed from the records
Walk deck gains F16 between the unguided experiment and the discussion:
act 2 (run_t5r -- zero crashes, everything self-diagnosed, ~596 um basin
stall) and act 3 (oi_walk -- 69.8 nm at the target box, 8531x better,
exit PASS every step; the signed clearance floor crossing the 25 mm knee
is the separately-stated residual).  All numbers via the new
rodgers3_records.parse_walk (t5_walk_REPORT.md + t5r_REPORT.md); the
discussion slide (now F17) gains the walk-is-compiled-knowledge exhibit
and its footnote closes the arc.  Story deck slide 8 gains the one-line
sequel pointer.  Style gate run: two fixes (restated table numbers,
superlative).  Both decks remain DRAFT pending sign-off.

Co-Authored-By: Claude Fable 5 <noreply@anthropic.com>
</commit_message>
<xml_diff>
--- a/mmacos/challenges/rodgers3/deck_rodgers3.pptx
+++ b/mmacos/challenges/rodgers3/deck_rodgers3.pptx
@@ -7268,6 +7268,22 @@
               <a:t>•  The second instrument (EPD 200 mm, F/2.5) exposed all of it and is retired for re-instancing; its layout figure — not a number — is what caught the defect.</a:t>
             </a:r>
           </a:p>
+          <a:p>
+            <a:pPr>
+              <a:spcAft>
+                <a:spcPts val="600"/>
+              </a:spcAft>
+            </a:pPr>
+            <a:r>
+              <a:rPr sz="1200" b="0">
+                <a:solidFill>
+                  <a:srgbClr val="282828"/>
+                </a:solidFill>
+                <a:latin typeface="Arial"/>
+              </a:rPr>
+              <a:t>•  And the lessons COMPILE: the continuation runner distilled from this arc (oi_walk — solve an easy field box, then walk it open with warm starts) lands a fresh, harder instance at 69.8 nm unattended, 8531x better than its cold start (the full experiment: companion deck, section F).</a:t>
+            </a:r>
+          </a:p>
         </p:txBody>
       </p:sp>
       <p:pic>

</xml_diff>